<commit_message>
aligned text in the presentation
</commit_message>
<xml_diff>
--- a/ML_Project_9_Group_3_Presentation.pptx
+++ b/ML_Project_9_Group_3_Presentation.pptx
@@ -1623,7 +1623,7 @@
   <p:cSld>
     <p:spTree>
       <p:nvGrpSpPr>
-        <p:cNvPr id="333" name="Shape 333"/>
+        <p:cNvPr id="334" name="Shape 334"/>
         <p:cNvGrpSpPr/>
         <p:nvPr/>
       </p:nvGrpSpPr>
@@ -1637,7 +1637,7 @@
       </p:grpSpPr>
       <p:sp>
         <p:nvSpPr>
-          <p:cNvPr id="334" name="Google Shape;334;h55f610596eb4887f_0_15:notes"/>
+          <p:cNvPr id="335" name="Google Shape;335;h55f610596eb4887f_0_15:notes"/>
           <p:cNvSpPr/>
           <p:nvPr>
             <p:ph idx="2" type="sldImg"/>
@@ -1672,7 +1672,7 @@
       </p:sp>
       <p:sp>
         <p:nvSpPr>
-          <p:cNvPr id="335" name="Google Shape;335;h55f610596eb4887f_0_15:notes"/>
+          <p:cNvPr id="336" name="Google Shape;336;h55f610596eb4887f_0_15:notes"/>
           <p:cNvSpPr txBox="1"/>
           <p:nvPr>
             <p:ph idx="1" type="body"/>
@@ -1722,7 +1722,7 @@
   <p:cSld>
     <p:spTree>
       <p:nvGrpSpPr>
-        <p:cNvPr id="352" name="Shape 352"/>
+        <p:cNvPr id="353" name="Shape 353"/>
         <p:cNvGrpSpPr/>
         <p:nvPr/>
       </p:nvGrpSpPr>
@@ -1736,7 +1736,7 @@
       </p:grpSpPr>
       <p:sp>
         <p:nvSpPr>
-          <p:cNvPr id="353" name="Google Shape;353;h55f610596eb4887f_0_20:notes"/>
+          <p:cNvPr id="354" name="Google Shape;354;h55f610596eb4887f_0_20:notes"/>
           <p:cNvSpPr/>
           <p:nvPr>
             <p:ph idx="2" type="sldImg"/>
@@ -1771,7 +1771,7 @@
       </p:sp>
       <p:sp>
         <p:nvSpPr>
-          <p:cNvPr id="354" name="Google Shape;354;h55f610596eb4887f_0_20:notes"/>
+          <p:cNvPr id="355" name="Google Shape;355;h55f610596eb4887f_0_20:notes"/>
           <p:cNvSpPr txBox="1"/>
           <p:nvPr>
             <p:ph idx="1" type="body"/>
@@ -1821,7 +1821,7 @@
   <p:cSld>
     <p:spTree>
       <p:nvGrpSpPr>
-        <p:cNvPr id="364" name="Shape 364"/>
+        <p:cNvPr id="365" name="Shape 365"/>
         <p:cNvGrpSpPr/>
         <p:nvPr/>
       </p:nvGrpSpPr>
@@ -1835,7 +1835,7 @@
       </p:grpSpPr>
       <p:sp>
         <p:nvSpPr>
-          <p:cNvPr id="365" name="Google Shape;365;p:notes"/>
+          <p:cNvPr id="366" name="Google Shape;366;p:notes"/>
           <p:cNvSpPr/>
           <p:nvPr>
             <p:ph idx="2" type="sldImg"/>
@@ -1870,7 +1870,7 @@
       </p:sp>
       <p:sp>
         <p:nvSpPr>
-          <p:cNvPr id="366" name="Google Shape;366;p:notes"/>
+          <p:cNvPr id="367" name="Google Shape;367;p:notes"/>
           <p:cNvSpPr txBox="1"/>
           <p:nvPr>
             <p:ph idx="1" type="body"/>
@@ -1920,7 +1920,7 @@
   <p:cSld>
     <p:spTree>
       <p:nvGrpSpPr>
-        <p:cNvPr id="375" name="Shape 375"/>
+        <p:cNvPr id="376" name="Shape 376"/>
         <p:cNvGrpSpPr/>
         <p:nvPr/>
       </p:nvGrpSpPr>
@@ -1934,7 +1934,7 @@
       </p:grpSpPr>
       <p:sp>
         <p:nvSpPr>
-          <p:cNvPr id="376" name="Google Shape;376;h55f610596eb4887f_0_0:notes"/>
+          <p:cNvPr id="377" name="Google Shape;377;h55f610596eb4887f_0_0:notes"/>
           <p:cNvSpPr/>
           <p:nvPr>
             <p:ph idx="2" type="sldImg"/>
@@ -1969,7 +1969,7 @@
       </p:sp>
       <p:sp>
         <p:nvSpPr>
-          <p:cNvPr id="377" name="Google Shape;377;h55f610596eb4887f_0_0:notes"/>
+          <p:cNvPr id="378" name="Google Shape;378;h55f610596eb4887f_0_0:notes"/>
           <p:cNvSpPr txBox="1"/>
           <p:nvPr>
             <p:ph idx="1" type="body"/>
@@ -2019,7 +2019,7 @@
   <p:cSld>
     <p:spTree>
       <p:nvGrpSpPr>
-        <p:cNvPr id="382" name="Shape 382"/>
+        <p:cNvPr id="383" name="Shape 383"/>
         <p:cNvGrpSpPr/>
         <p:nvPr/>
       </p:nvGrpSpPr>
@@ -2033,7 +2033,7 @@
       </p:grpSpPr>
       <p:sp>
         <p:nvSpPr>
-          <p:cNvPr id="383" name="Google Shape;383;h55f610596eb4887f_0_5:notes"/>
+          <p:cNvPr id="384" name="Google Shape;384;h55f610596eb4887f_0_5:notes"/>
           <p:cNvSpPr/>
           <p:nvPr>
             <p:ph idx="2" type="sldImg"/>
@@ -2068,7 +2068,7 @@
       </p:sp>
       <p:sp>
         <p:nvSpPr>
-          <p:cNvPr id="384" name="Google Shape;384;h55f610596eb4887f_0_5:notes"/>
+          <p:cNvPr id="385" name="Google Shape;385;h55f610596eb4887f_0_5:notes"/>
           <p:cNvSpPr txBox="1"/>
           <p:nvPr>
             <p:ph idx="1" type="body"/>
@@ -2275,7 +2275,7 @@
   <p:cSld>
     <p:spTree>
       <p:nvGrpSpPr>
-        <p:cNvPr id="389" name="Shape 389"/>
+        <p:cNvPr id="390" name="Shape 390"/>
         <p:cNvGrpSpPr/>
         <p:nvPr/>
       </p:nvGrpSpPr>
@@ -2289,7 +2289,7 @@
       </p:grpSpPr>
       <p:sp>
         <p:nvSpPr>
-          <p:cNvPr id="390" name="Google Shape;390;h55f610596eb4887f_0_10:notes"/>
+          <p:cNvPr id="391" name="Google Shape;391;h55f610596eb4887f_0_10:notes"/>
           <p:cNvSpPr/>
           <p:nvPr>
             <p:ph idx="2" type="sldImg"/>
@@ -2324,7 +2324,7 @@
       </p:sp>
       <p:sp>
         <p:nvSpPr>
-          <p:cNvPr id="391" name="Google Shape;391;h55f610596eb4887f_0_10:notes"/>
+          <p:cNvPr id="392" name="Google Shape;392;h55f610596eb4887f_0_10:notes"/>
           <p:cNvSpPr txBox="1"/>
           <p:nvPr>
             <p:ph idx="1" type="body"/>
@@ -2374,7 +2374,7 @@
   <p:cSld>
     <p:spTree>
       <p:nvGrpSpPr>
-        <p:cNvPr id="396" name="Shape 396"/>
+        <p:cNvPr id="397" name="Shape 397"/>
         <p:cNvGrpSpPr/>
         <p:nvPr/>
       </p:nvGrpSpPr>
@@ -2388,7 +2388,7 @@
       </p:grpSpPr>
       <p:sp>
         <p:nvSpPr>
-          <p:cNvPr id="397" name="Google Shape;397;h1eb388ce2fcb6e8_2_0:notes"/>
+          <p:cNvPr id="398" name="Google Shape;398;h1eb388ce2fcb6e8_2_0:notes"/>
           <p:cNvSpPr/>
           <p:nvPr>
             <p:ph idx="2" type="sldImg"/>
@@ -2423,7 +2423,7 @@
       </p:sp>
       <p:sp>
         <p:nvSpPr>
-          <p:cNvPr id="398" name="Google Shape;398;h1eb388ce2fcb6e8_2_0:notes"/>
+          <p:cNvPr id="399" name="Google Shape;399;h1eb388ce2fcb6e8_2_0:notes"/>
           <p:cNvSpPr txBox="1"/>
           <p:nvPr>
             <p:ph idx="1" type="body"/>
@@ -2473,7 +2473,7 @@
   <p:cSld>
     <p:spTree>
       <p:nvGrpSpPr>
-        <p:cNvPr id="403" name="Shape 403"/>
+        <p:cNvPr id="404" name="Shape 404"/>
         <p:cNvGrpSpPr/>
         <p:nvPr/>
       </p:nvGrpSpPr>
@@ -2487,7 +2487,7 @@
       </p:grpSpPr>
       <p:sp>
         <p:nvSpPr>
-          <p:cNvPr id="404" name="Google Shape;404;h2c8f91d5f6982453_13_0:notes"/>
+          <p:cNvPr id="405" name="Google Shape;405;h2c8f91d5f6982453_13_0:notes"/>
           <p:cNvSpPr/>
           <p:nvPr>
             <p:ph idx="2" type="sldImg"/>
@@ -2532,7 +2532,7 @@
       </p:sp>
       <p:sp>
         <p:nvSpPr>
-          <p:cNvPr id="405" name="Google Shape;405;h2c8f91d5f6982453_13_0:notes"/>
+          <p:cNvPr id="406" name="Google Shape;406;h2c8f91d5f6982453_13_0:notes"/>
           <p:cNvSpPr txBox="1"/>
           <p:nvPr>
             <p:ph idx="1" type="body"/>
@@ -2575,7 +2575,7 @@
       </p:sp>
       <p:sp>
         <p:nvSpPr>
-          <p:cNvPr id="406" name="Google Shape;406;h2c8f91d5f6982453_13_0:notes"/>
+          <p:cNvPr id="407" name="Google Shape;407;h2c8f91d5f6982453_13_0:notes"/>
           <p:cNvSpPr txBox="1"/>
           <p:nvPr>
             <p:ph idx="12" type="sldNum"/>
@@ -20351,8 +20351,8 @@
         </p:nvSpPr>
         <p:spPr>
           <a:xfrm>
-            <a:off x="2989851" y="3053322"/>
-            <a:ext cx="3164295" cy="276999"/>
+            <a:off x="2854200" y="3053325"/>
+            <a:ext cx="3435600" cy="284700"/>
           </a:xfrm>
           <a:prstGeom prst="rect">
             <a:avLst/>
@@ -20468,7 +20468,7 @@
             </a:r>
             <a:r>
               <a:rPr lang="en" sz="3300"/>
-              <a:t>              </a:t>
+              <a:t>           </a:t>
             </a:r>
             <a:r>
               <a:rPr b="1" lang="en" sz="3300">
@@ -20477,7 +20477,7 @@
                 <a:cs typeface="Arial"/>
                 <a:sym typeface="Arial"/>
               </a:rPr>
-              <a:t>Linear Model: Evaluation Result</a:t>
+              <a:t>Linear Regression: Evaluation Result</a:t>
             </a:r>
             <a:r>
               <a:rPr b="1" lang="en" sz="3300">
@@ -20832,7 +20832,7 @@
             <a:tbl>
               <a:tblPr bandRow="1" firstRow="1">
                 <a:noFill/>
-                <a:tableStyleId>{8DD880F3-B267-4A19-8CC4-8528E6AE9A93}</a:tableStyleId>
+                <a:tableStyleId>{33845540-4549-48E9-B17C-92D9A22C0115}</a:tableStyleId>
               </a:tblPr>
               <a:tblGrid>
                 <a:gridCol w="3789000"/>
@@ -21256,7 +21256,7 @@
         </p:spPr>
         <p:txBody>
           <a:bodyPr anchorCtr="0" anchor="t" bIns="0" lIns="0" spcFirstLastPara="1" rIns="0" wrap="square" tIns="0">
-            <a:normAutofit/>
+            <a:normAutofit fontScale="90000"/>
           </a:bodyPr>
           <a:lstStyle/>
           <a:p>
@@ -21273,23 +21273,28 @@
               <a:buClr>
                 <a:srgbClr val="1B2A3A"/>
               </a:buClr>
-              <a:buSzPts val="4200"/>
+              <a:buSzPct val="100000"/>
               <a:buFont typeface="Georgia"/>
               <a:buNone/>
             </a:pPr>
             <a:r>
-              <a:rPr b="0" i="0" lang="en" sz="4200">
+              <a:rPr b="1" i="0" lang="en" sz="4200">
                 <a:solidFill>
                   <a:srgbClr val="1B2A3A"/>
                 </a:solidFill>
-                <a:latin typeface="Georgia"/>
-                <a:ea typeface="Georgia"/>
-                <a:cs typeface="Georgia"/>
-                <a:sym typeface="Georgia"/>
+                <a:latin typeface="Arial"/>
+                <a:ea typeface="Arial"/>
+                <a:cs typeface="Arial"/>
+                <a:sym typeface="Arial"/>
               </a:rPr>
               <a:t>Decision Tree Regressor</a:t>
             </a:r>
-            <a:endParaRPr sz="4200"/>
+            <a:endParaRPr b="1" sz="4200">
+              <a:latin typeface="Arial"/>
+              <a:ea typeface="Arial"/>
+              <a:cs typeface="Arial"/>
+              <a:sym typeface="Arial"/>
+            </a:endParaRPr>
           </a:p>
         </p:txBody>
       </p:sp>
@@ -21401,8 +21406,8 @@
         </p:nvSpPr>
         <p:spPr>
           <a:xfrm>
-            <a:off x="609600" y="609600"/>
-            <a:ext cx="8162544" cy="396240"/>
+            <a:off x="609600" y="232350"/>
+            <a:ext cx="8162400" cy="396300"/>
           </a:xfrm>
           <a:prstGeom prst="rect">
             <a:avLst/>
@@ -21414,7 +21419,7 @@
         </p:spPr>
         <p:txBody>
           <a:bodyPr anchorCtr="0" anchor="t" bIns="0" lIns="0" spcFirstLastPara="1" rIns="0" wrap="square" tIns="0">
-            <a:normAutofit/>
+            <a:noAutofit/>
           </a:bodyPr>
           <a:lstStyle/>
           <a:p>
@@ -21431,23 +21436,37 @@
               <a:buClr>
                 <a:srgbClr val="1B2A3A"/>
               </a:buClr>
-              <a:buSzPts val="2700"/>
+              <a:buSzPts val="2430"/>
               <a:buFont typeface="Georgia"/>
               <a:buNone/>
             </a:pPr>
             <a:r>
-              <a:rPr b="0" i="0" lang="en" sz="2700">
+              <a:rPr b="1" lang="en" sz="3130">
+                <a:latin typeface="Arial"/>
+                <a:ea typeface="Arial"/>
+                <a:cs typeface="Arial"/>
+                <a:sym typeface="Arial"/>
+              </a:rPr>
+              <a:t>                  </a:t>
+            </a:r>
+            <a:r>
+              <a:rPr b="1" i="0" lang="en" sz="3330">
                 <a:solidFill>
                   <a:srgbClr val="1B2A3A"/>
                 </a:solidFill>
-                <a:latin typeface="Georgia"/>
-                <a:ea typeface="Georgia"/>
-                <a:cs typeface="Georgia"/>
-                <a:sym typeface="Georgia"/>
+                <a:latin typeface="Arial"/>
+                <a:ea typeface="Arial"/>
+                <a:cs typeface="Arial"/>
+                <a:sym typeface="Arial"/>
               </a:rPr>
               <a:t>Effect of tree depth</a:t>
             </a:r>
-            <a:endParaRPr sz="2700"/>
+            <a:endParaRPr b="1" sz="3330">
+              <a:latin typeface="Arial"/>
+              <a:ea typeface="Arial"/>
+              <a:cs typeface="Arial"/>
+              <a:sym typeface="Arial"/>
+            </a:endParaRPr>
           </a:p>
         </p:txBody>
       </p:sp>
@@ -21835,8 +21854,8 @@
         </p:nvSpPr>
         <p:spPr>
           <a:xfrm>
-            <a:off x="609600" y="609600"/>
-            <a:ext cx="8162544" cy="396240"/>
+            <a:off x="609600" y="296925"/>
+            <a:ext cx="8162400" cy="396300"/>
           </a:xfrm>
           <a:prstGeom prst="rect">
             <a:avLst/>
@@ -21848,11 +21867,11 @@
         </p:spPr>
         <p:txBody>
           <a:bodyPr anchorCtr="0" anchor="t" bIns="0" lIns="0" spcFirstLastPara="1" rIns="0" wrap="square" tIns="0">
-            <a:normAutofit/>
+            <a:noAutofit/>
           </a:bodyPr>
           <a:lstStyle/>
           <a:p>
-            <a:pPr indent="0" lvl="0" marL="0" rtl="0" algn="l">
+            <a:pPr indent="0" lvl="0" marL="0" rtl="0" algn="ctr">
               <a:lnSpc>
                 <a:spcPct val="110000"/>
               </a:lnSpc>
@@ -21865,23 +21884,28 @@
               <a:buClr>
                 <a:srgbClr val="1B2A3A"/>
               </a:buClr>
-              <a:buSzPts val="2700"/>
+              <a:buSzPts val="2430"/>
               <a:buFont typeface="Georgia"/>
               <a:buNone/>
             </a:pPr>
             <a:r>
-              <a:rPr b="0" i="0" lang="en" sz="2700">
+              <a:rPr b="1" i="0" lang="en" sz="3330">
                 <a:solidFill>
                   <a:srgbClr val="1B2A3A"/>
                 </a:solidFill>
-                <a:latin typeface="Georgia"/>
-                <a:ea typeface="Georgia"/>
-                <a:cs typeface="Georgia"/>
-                <a:sym typeface="Georgia"/>
+                <a:latin typeface="Arial"/>
+                <a:ea typeface="Arial"/>
+                <a:cs typeface="Arial"/>
+                <a:sym typeface="Arial"/>
               </a:rPr>
               <a:t>Generalization check</a:t>
             </a:r>
-            <a:endParaRPr sz="2700"/>
+            <a:endParaRPr b="1" sz="3330">
+              <a:latin typeface="Arial"/>
+              <a:ea typeface="Arial"/>
+              <a:cs typeface="Arial"/>
+              <a:sym typeface="Arial"/>
+            </a:endParaRPr>
           </a:p>
         </p:txBody>
       </p:sp>
@@ -21927,7 +21951,7 @@
             <a:tbl>
               <a:tblPr>
                 <a:noFill/>
-                <a:tableStyleId>{F8EE354C-3E2A-4422-89BC-CC35F2F1C3C6}</a:tableStyleId>
+                <a:tableStyleId>{D04487E2-8379-458E-89A5-9EFA157CD851}</a:tableStyleId>
               </a:tblPr>
               <a:tblGrid>
                 <a:gridCol w="975350"/>
@@ -23218,8 +23242,8 @@
         </p:nvSpPr>
         <p:spPr>
           <a:xfrm>
-            <a:off x="609600" y="609600"/>
-            <a:ext cx="8162544" cy="396240"/>
+            <a:off x="609600" y="328200"/>
+            <a:ext cx="8162400" cy="396300"/>
           </a:xfrm>
           <a:prstGeom prst="rect">
             <a:avLst/>
@@ -23231,11 +23255,11 @@
         </p:spPr>
         <p:txBody>
           <a:bodyPr anchorCtr="0" anchor="t" bIns="0" lIns="0" spcFirstLastPara="1" rIns="0" wrap="square" tIns="0">
-            <a:normAutofit/>
+            <a:noAutofit/>
           </a:bodyPr>
           <a:lstStyle/>
           <a:p>
-            <a:pPr indent="0" lvl="0" marL="0" rtl="0" algn="l">
+            <a:pPr indent="0" lvl="0" marL="0" rtl="0" algn="ctr">
               <a:lnSpc>
                 <a:spcPct val="110000"/>
               </a:lnSpc>
@@ -23248,23 +23272,28 @@
               <a:buClr>
                 <a:srgbClr val="1B2A3A"/>
               </a:buClr>
-              <a:buSzPts val="2700"/>
+              <a:buSzPts val="2430"/>
               <a:buFont typeface="Georgia"/>
               <a:buNone/>
             </a:pPr>
             <a:r>
-              <a:rPr b="0" i="0" lang="en" sz="2700">
+              <a:rPr b="1" i="0" lang="en" sz="3330">
                 <a:solidFill>
                   <a:srgbClr val="1B2A3A"/>
                 </a:solidFill>
-                <a:latin typeface="Georgia"/>
-                <a:ea typeface="Georgia"/>
-                <a:cs typeface="Georgia"/>
-                <a:sym typeface="Georgia"/>
+                <a:latin typeface="Arial"/>
+                <a:ea typeface="Arial"/>
+                <a:cs typeface="Arial"/>
+                <a:sym typeface="Arial"/>
               </a:rPr>
               <a:t>Error by building type</a:t>
             </a:r>
-            <a:endParaRPr sz="2700"/>
+            <a:endParaRPr b="1" sz="3330">
+              <a:latin typeface="Arial"/>
+              <a:ea typeface="Arial"/>
+              <a:cs typeface="Arial"/>
+              <a:sym typeface="Arial"/>
+            </a:endParaRPr>
           </a:p>
         </p:txBody>
       </p:sp>
@@ -23610,6 +23639,51 @@
           </a:p>
         </p:txBody>
       </p:sp>
+      <p:sp>
+        <p:nvSpPr>
+          <p:cNvPr id="333" name="Google Shape;333;p42"/>
+          <p:cNvSpPr txBox="1"/>
+          <p:nvPr/>
+        </p:nvSpPr>
+        <p:spPr>
+          <a:xfrm>
+            <a:off x="3116325" y="839000"/>
+            <a:ext cx="6045000" cy="369300"/>
+          </a:xfrm>
+          <a:prstGeom prst="rect">
+            <a:avLst/>
+          </a:prstGeom>
+          <a:noFill/>
+          <a:ln>
+            <a:noFill/>
+          </a:ln>
+        </p:spPr>
+        <p:txBody>
+          <a:bodyPr anchorCtr="0" anchor="t" bIns="91425" lIns="91425" spcFirstLastPara="1" rIns="91425" wrap="square" tIns="91425">
+            <a:spAutoFit/>
+          </a:bodyPr>
+          <a:lstStyle/>
+          <a:p>
+            <a:pPr indent="0" lvl="0" marL="0" rtl="0" algn="l">
+              <a:spcBef>
+                <a:spcPts val="0"/>
+              </a:spcBef>
+              <a:spcAft>
+                <a:spcPts val="0"/>
+              </a:spcAft>
+              <a:buNone/>
+            </a:pPr>
+            <a:r>
+              <a:t/>
+            </a:r>
+            <a:endParaRPr sz="1200">
+              <a:solidFill>
+                <a:srgbClr val="1B2A3A"/>
+              </a:solidFill>
+            </a:endParaRPr>
+          </a:p>
+        </p:txBody>
+      </p:sp>
     </p:spTree>
   </p:cSld>
   <p:clrMapOvr>
@@ -23623,7 +23697,7 @@
   <p:cSld>
     <p:spTree>
       <p:nvGrpSpPr>
-        <p:cNvPr id="336" name="Shape 336"/>
+        <p:cNvPr id="337" name="Shape 337"/>
         <p:cNvGrpSpPr/>
         <p:nvPr/>
       </p:nvGrpSpPr>
@@ -23637,7 +23711,7 @@
       </p:grpSpPr>
       <p:sp>
         <p:nvSpPr>
-          <p:cNvPr id="337" name="Google Shape;337;p43"/>
+          <p:cNvPr id="338" name="Google Shape;338;p43"/>
           <p:cNvSpPr txBox="1"/>
           <p:nvPr>
             <p:ph idx="4294967295" type="ctrTitle"/>
@@ -23696,7 +23770,7 @@
       </p:sp>
       <p:sp>
         <p:nvSpPr>
-          <p:cNvPr id="338" name="Google Shape;338;p43"/>
+          <p:cNvPr id="339" name="Google Shape;339;p43"/>
           <p:cNvSpPr/>
           <p:nvPr/>
         </p:nvSpPr>
@@ -23753,7 +23827,7 @@
       </p:sp>
       <p:sp>
         <p:nvSpPr>
-          <p:cNvPr id="339" name="Google Shape;339;p43"/>
+          <p:cNvPr id="340" name="Google Shape;340;p43"/>
           <p:cNvSpPr txBox="1"/>
           <p:nvPr/>
         </p:nvSpPr>
@@ -23926,7 +24000,7 @@
       </p:sp>
       <p:sp>
         <p:nvSpPr>
-          <p:cNvPr id="340" name="Google Shape;340;p43"/>
+          <p:cNvPr id="341" name="Google Shape;341;p43"/>
           <p:cNvSpPr/>
           <p:nvPr/>
         </p:nvSpPr>
@@ -23985,7 +24059,7 @@
       </p:sp>
       <p:sp>
         <p:nvSpPr>
-          <p:cNvPr id="341" name="Google Shape;341;p43"/>
+          <p:cNvPr id="342" name="Google Shape;342;p43"/>
           <p:cNvSpPr txBox="1"/>
           <p:nvPr/>
         </p:nvSpPr>
@@ -24035,7 +24109,7 @@
       </p:sp>
       <p:sp>
         <p:nvSpPr>
-          <p:cNvPr id="342" name="Google Shape;342;p43"/>
+          <p:cNvPr id="343" name="Google Shape;343;p43"/>
           <p:cNvSpPr/>
           <p:nvPr/>
         </p:nvSpPr>
@@ -24092,7 +24166,7 @@
       </p:sp>
       <p:sp>
         <p:nvSpPr>
-          <p:cNvPr id="343" name="Google Shape;343;p43"/>
+          <p:cNvPr id="344" name="Google Shape;344;p43"/>
           <p:cNvSpPr txBox="1"/>
           <p:nvPr/>
         </p:nvSpPr>
@@ -24225,7 +24299,7 @@
       </p:sp>
       <p:sp>
         <p:nvSpPr>
-          <p:cNvPr id="344" name="Google Shape;344;p43"/>
+          <p:cNvPr id="345" name="Google Shape;345;p43"/>
           <p:cNvSpPr/>
           <p:nvPr/>
         </p:nvSpPr>
@@ -24284,7 +24358,7 @@
       </p:sp>
       <p:sp>
         <p:nvSpPr>
-          <p:cNvPr id="345" name="Google Shape;345;p43"/>
+          <p:cNvPr id="346" name="Google Shape;346;p43"/>
           <p:cNvSpPr/>
           <p:nvPr/>
         </p:nvSpPr>
@@ -24343,7 +24417,7 @@
       </p:sp>
       <p:sp>
         <p:nvSpPr>
-          <p:cNvPr id="346" name="Google Shape;346;p43"/>
+          <p:cNvPr id="347" name="Google Shape;347;p43"/>
           <p:cNvSpPr/>
           <p:nvPr/>
         </p:nvSpPr>
@@ -24400,7 +24474,7 @@
       </p:sp>
       <p:sp>
         <p:nvSpPr>
-          <p:cNvPr id="347" name="Google Shape;347;p43"/>
+          <p:cNvPr id="348" name="Google Shape;348;p43"/>
           <p:cNvSpPr/>
           <p:nvPr/>
         </p:nvSpPr>
@@ -24457,7 +24531,7 @@
       </p:sp>
       <p:sp>
         <p:nvSpPr>
-          <p:cNvPr id="348" name="Google Shape;348;p43"/>
+          <p:cNvPr id="349" name="Google Shape;349;p43"/>
           <p:cNvSpPr txBox="1"/>
           <p:nvPr/>
         </p:nvSpPr>
@@ -24538,7 +24612,7 @@
       </p:sp>
       <p:sp>
         <p:nvSpPr>
-          <p:cNvPr id="349" name="Google Shape;349;p43"/>
+          <p:cNvPr id="350" name="Google Shape;350;p43"/>
           <p:cNvSpPr txBox="1"/>
           <p:nvPr/>
         </p:nvSpPr>
@@ -24668,7 +24742,7 @@
       </p:sp>
       <p:sp>
         <p:nvSpPr>
-          <p:cNvPr id="350" name="Google Shape;350;p43"/>
+          <p:cNvPr id="351" name="Google Shape;351;p43"/>
           <p:cNvSpPr txBox="1"/>
           <p:nvPr/>
         </p:nvSpPr>
@@ -24741,7 +24815,7 @@
       </p:sp>
       <p:sp>
         <p:nvSpPr>
-          <p:cNvPr id="351" name="Google Shape;351;p43"/>
+          <p:cNvPr id="352" name="Google Shape;352;p43"/>
           <p:cNvSpPr txBox="1"/>
           <p:nvPr/>
         </p:nvSpPr>
@@ -24875,7 +24949,7 @@
   <p:cSld>
     <p:spTree>
       <p:nvGrpSpPr>
-        <p:cNvPr id="355" name="Shape 355"/>
+        <p:cNvPr id="356" name="Shape 356"/>
         <p:cNvGrpSpPr/>
         <p:nvPr/>
       </p:nvGrpSpPr>
@@ -24889,7 +24963,7 @@
       </p:grpSpPr>
       <p:sp>
         <p:nvSpPr>
-          <p:cNvPr id="356" name="Google Shape;356;p44"/>
+          <p:cNvPr id="357" name="Google Shape;357;p44"/>
           <p:cNvSpPr txBox="1"/>
           <p:nvPr>
             <p:ph idx="4294967295" type="ctrTitle"/>
@@ -24957,7 +25031,7 @@
       </p:sp>
       <p:sp>
         <p:nvSpPr>
-          <p:cNvPr id="357" name="Google Shape;357;p44"/>
+          <p:cNvPr id="358" name="Google Shape;358;p44"/>
           <p:cNvSpPr/>
           <p:nvPr/>
         </p:nvSpPr>
@@ -25014,7 +25088,7 @@
       </p:sp>
       <p:sp>
         <p:nvSpPr>
-          <p:cNvPr id="358" name="Google Shape;358;p44"/>
+          <p:cNvPr id="359" name="Google Shape;359;p44"/>
           <p:cNvSpPr txBox="1"/>
           <p:nvPr/>
         </p:nvSpPr>
@@ -25036,78 +25110,6 @@
             <a:spAutoFit/>
           </a:bodyPr>
           <a:lstStyle/>
-          <a:p>
-            <a:pPr indent="0" lvl="0" marL="0" marR="0" rtl="0" algn="l">
-              <a:spcBef>
-                <a:spcPts val="0"/>
-              </a:spcBef>
-              <a:spcAft>
-                <a:spcPts val="0"/>
-              </a:spcAft>
-              <a:buNone/>
-            </a:pPr>
-            <a:r>
-              <a:t/>
-            </a:r>
-            <a:endParaRPr sz="1400">
-              <a:solidFill>
-                <a:schemeClr val="dk1"/>
-              </a:solidFill>
-              <a:latin typeface="Arial"/>
-              <a:ea typeface="Arial"/>
-              <a:cs typeface="Arial"/>
-              <a:sym typeface="Arial"/>
-            </a:endParaRPr>
-          </a:p>
-        </p:txBody>
-      </p:sp>
-      <p:sp>
-        <p:nvSpPr>
-          <p:cNvPr id="359" name="Google Shape;359;p44"/>
-          <p:cNvSpPr txBox="1"/>
-          <p:nvPr/>
-        </p:nvSpPr>
-        <p:spPr>
-          <a:xfrm>
-            <a:off x="1941305" y="1900674"/>
-            <a:ext cx="464100" cy="700200"/>
-          </a:xfrm>
-          <a:prstGeom prst="rect">
-            <a:avLst/>
-          </a:prstGeom>
-          <a:noFill/>
-          <a:ln>
-            <a:noFill/>
-          </a:ln>
-        </p:spPr>
-        <p:txBody>
-          <a:bodyPr anchorCtr="0" anchor="t" bIns="34275" lIns="68575" spcFirstLastPara="1" rIns="68575" wrap="square" tIns="34275">
-            <a:spAutoFit/>
-          </a:bodyPr>
-          <a:lstStyle/>
-          <a:p>
-            <a:pPr indent="0" lvl="0" marL="0" marR="0" rtl="0" algn="l">
-              <a:spcBef>
-                <a:spcPts val="0"/>
-              </a:spcBef>
-              <a:spcAft>
-                <a:spcPts val="0"/>
-              </a:spcAft>
-              <a:buNone/>
-            </a:pPr>
-            <a:r>
-              <a:t/>
-            </a:r>
-            <a:endParaRPr b="1" sz="2700">
-              <a:solidFill>
-                <a:schemeClr val="dk1"/>
-              </a:solidFill>
-              <a:latin typeface="Arial"/>
-              <a:ea typeface="Arial"/>
-              <a:cs typeface="Arial"/>
-              <a:sym typeface="Arial"/>
-            </a:endParaRPr>
-          </a:p>
           <a:p>
             <a:pPr indent="0" lvl="0" marL="0" marR="0" rtl="0" algn="l">
               <a:spcBef>
@@ -25141,8 +25143,8 @@
         </p:nvSpPr>
         <p:spPr>
           <a:xfrm>
-            <a:off x="3893191" y="1911616"/>
-            <a:ext cx="506100" cy="700200"/>
+            <a:off x="1941305" y="1900674"/>
+            <a:ext cx="464100" cy="700200"/>
           </a:xfrm>
           <a:prstGeom prst="rect">
             <a:avLst/>
@@ -25213,6 +25215,78 @@
         </p:nvSpPr>
         <p:spPr>
           <a:xfrm>
+            <a:off x="3893191" y="1911616"/>
+            <a:ext cx="506100" cy="700200"/>
+          </a:xfrm>
+          <a:prstGeom prst="rect">
+            <a:avLst/>
+          </a:prstGeom>
+          <a:noFill/>
+          <a:ln>
+            <a:noFill/>
+          </a:ln>
+        </p:spPr>
+        <p:txBody>
+          <a:bodyPr anchorCtr="0" anchor="t" bIns="34275" lIns="68575" spcFirstLastPara="1" rIns="68575" wrap="square" tIns="34275">
+            <a:spAutoFit/>
+          </a:bodyPr>
+          <a:lstStyle/>
+          <a:p>
+            <a:pPr indent="0" lvl="0" marL="0" marR="0" rtl="0" algn="l">
+              <a:spcBef>
+                <a:spcPts val="0"/>
+              </a:spcBef>
+              <a:spcAft>
+                <a:spcPts val="0"/>
+              </a:spcAft>
+              <a:buNone/>
+            </a:pPr>
+            <a:r>
+              <a:t/>
+            </a:r>
+            <a:endParaRPr b="1" sz="2700">
+              <a:solidFill>
+                <a:schemeClr val="dk1"/>
+              </a:solidFill>
+              <a:latin typeface="Arial"/>
+              <a:ea typeface="Arial"/>
+              <a:cs typeface="Arial"/>
+              <a:sym typeface="Arial"/>
+            </a:endParaRPr>
+          </a:p>
+          <a:p>
+            <a:pPr indent="0" lvl="0" marL="0" marR="0" rtl="0" algn="l">
+              <a:spcBef>
+                <a:spcPts val="0"/>
+              </a:spcBef>
+              <a:spcAft>
+                <a:spcPts val="0"/>
+              </a:spcAft>
+              <a:buNone/>
+            </a:pPr>
+            <a:r>
+              <a:t/>
+            </a:r>
+            <a:endParaRPr sz="1400">
+              <a:solidFill>
+                <a:schemeClr val="dk1"/>
+              </a:solidFill>
+              <a:latin typeface="Arial"/>
+              <a:ea typeface="Arial"/>
+              <a:cs typeface="Arial"/>
+              <a:sym typeface="Arial"/>
+            </a:endParaRPr>
+          </a:p>
+        </p:txBody>
+      </p:sp>
+      <p:sp>
+        <p:nvSpPr>
+          <p:cNvPr id="362" name="Google Shape;362;p44"/>
+          <p:cNvSpPr txBox="1"/>
+          <p:nvPr/>
+        </p:nvSpPr>
+        <p:spPr>
+          <a:xfrm>
             <a:off x="5937230" y="1900674"/>
             <a:ext cx="138600" cy="700200"/>
           </a:xfrm>
@@ -25279,7 +25353,7 @@
       </p:sp>
       <p:graphicFrame>
         <p:nvGraphicFramePr>
-          <p:cNvPr id="362" name="Google Shape;362;p44"/>
+          <p:cNvPr id="363" name="Google Shape;363;p44"/>
           <p:cNvGraphicFramePr/>
           <p:nvPr/>
         </p:nvGraphicFramePr>
@@ -25292,7 +25366,7 @@
             <a:tbl>
               <a:tblPr bandRow="1" firstRow="1">
                 <a:noFill/>
-                <a:tableStyleId>{8DD880F3-B267-4A19-8CC4-8528E6AE9A93}</a:tableStyleId>
+                <a:tableStyleId>{33845540-4549-48E9-B17C-92D9A22C0115}</a:tableStyleId>
               </a:tblPr>
               <a:tblGrid>
                 <a:gridCol w="3789000"/>
@@ -25547,7 +25621,7 @@
       </p:graphicFrame>
       <p:sp>
         <p:nvSpPr>
-          <p:cNvPr id="363" name="Google Shape;363;p44"/>
+          <p:cNvPr id="364" name="Google Shape;364;p44"/>
           <p:cNvSpPr txBox="1"/>
           <p:nvPr/>
         </p:nvSpPr>
@@ -25608,7 +25682,7 @@
   <p:cSld>
     <p:spTree>
       <p:nvGrpSpPr>
-        <p:cNvPr id="367" name="Shape 367"/>
+        <p:cNvPr id="368" name="Shape 368"/>
         <p:cNvGrpSpPr/>
         <p:nvPr/>
       </p:nvGrpSpPr>
@@ -25622,7 +25696,7 @@
       </p:grpSpPr>
       <p:sp>
         <p:nvSpPr>
-          <p:cNvPr id="368" name="Google Shape;368;p45"/>
+          <p:cNvPr id="369" name="Google Shape;369;p45"/>
           <p:cNvSpPr txBox="1"/>
           <p:nvPr>
             <p:ph idx="1" type="subTitle"/>
@@ -25774,7 +25848,7 @@
       </p:sp>
       <p:sp>
         <p:nvSpPr>
-          <p:cNvPr id="369" name="Google Shape;369;p45"/>
+          <p:cNvPr id="370" name="Google Shape;370;p45"/>
           <p:cNvSpPr txBox="1"/>
           <p:nvPr/>
         </p:nvSpPr>
@@ -25854,7 +25928,7 @@
       </p:sp>
       <p:sp>
         <p:nvSpPr>
-          <p:cNvPr id="370" name="Google Shape;370;p45"/>
+          <p:cNvPr id="371" name="Google Shape;371;p45"/>
           <p:cNvSpPr txBox="1"/>
           <p:nvPr/>
         </p:nvSpPr>
@@ -25934,7 +26008,7 @@
       </p:sp>
       <p:sp>
         <p:nvSpPr>
-          <p:cNvPr id="371" name="Google Shape;371;p45"/>
+          <p:cNvPr id="372" name="Google Shape;372;p45"/>
           <p:cNvSpPr txBox="1"/>
           <p:nvPr/>
         </p:nvSpPr>
@@ -26033,7 +26107,7 @@
       </p:sp>
       <p:sp>
         <p:nvSpPr>
-          <p:cNvPr id="372" name="Google Shape;372;p45"/>
+          <p:cNvPr id="373" name="Google Shape;373;p45"/>
           <p:cNvSpPr txBox="1"/>
           <p:nvPr/>
         </p:nvSpPr>
@@ -26132,7 +26206,7 @@
       </p:sp>
       <p:pic>
         <p:nvPicPr>
-          <p:cNvPr id="373" name="Google Shape;373;p45" title="WhatsApp Image 2026-10-24 at 20.25.17.jpeg"/>
+          <p:cNvPr id="374" name="Google Shape;374;p45" title="WhatsApp Image 2026-10-24 at 20.25.17.jpeg"/>
           <p:cNvPicPr preferRelativeResize="0"/>
           <p:nvPr/>
         </p:nvPicPr>
@@ -26160,7 +26234,7 @@
       </p:pic>
       <p:sp>
         <p:nvSpPr>
-          <p:cNvPr id="374" name="Google Shape;374;p45"/>
+          <p:cNvPr id="375" name="Google Shape;375;p45"/>
           <p:cNvSpPr txBox="1"/>
           <p:nvPr/>
         </p:nvSpPr>
@@ -26289,7 +26363,7 @@
   <p:cSld>
     <p:spTree>
       <p:nvGrpSpPr>
-        <p:cNvPr id="378" name="Shape 378"/>
+        <p:cNvPr id="379" name="Shape 379"/>
         <p:cNvGrpSpPr/>
         <p:nvPr/>
       </p:nvGrpSpPr>
@@ -26303,7 +26377,7 @@
       </p:grpSpPr>
       <p:sp>
         <p:nvSpPr>
-          <p:cNvPr id="379" name="Google Shape;379;p46"/>
+          <p:cNvPr id="380" name="Google Shape;380;p46"/>
           <p:cNvSpPr txBox="1"/>
           <p:nvPr>
             <p:ph type="title"/>
@@ -26447,7 +26521,7 @@
       </p:sp>
       <p:sp>
         <p:nvSpPr>
-          <p:cNvPr id="380" name="Google Shape;380;p46"/>
+          <p:cNvPr id="381" name="Google Shape;381;p46"/>
           <p:cNvSpPr txBox="1"/>
           <p:nvPr/>
         </p:nvSpPr>
@@ -26572,7 +26646,7 @@
       </p:sp>
       <p:pic>
         <p:nvPicPr>
-          <p:cNvPr id="381" name="Google Shape;381;p46" title="WhatsApp Image 2026-10-24 at 20.25.17 (1).jpeg"/>
+          <p:cNvPr id="382" name="Google Shape;382;p46" title="WhatsApp Image 2026-10-24 at 20.25.17 (1).jpeg"/>
           <p:cNvPicPr preferRelativeResize="0"/>
           <p:nvPr/>
         </p:nvPicPr>
@@ -26611,7 +26685,7 @@
   <p:cSld>
     <p:spTree>
       <p:nvGrpSpPr>
-        <p:cNvPr id="385" name="Shape 385"/>
+        <p:cNvPr id="386" name="Shape 386"/>
         <p:cNvGrpSpPr/>
         <p:nvPr/>
       </p:nvGrpSpPr>
@@ -26625,7 +26699,7 @@
       </p:grpSpPr>
       <p:sp>
         <p:nvSpPr>
-          <p:cNvPr id="386" name="Google Shape;386;p47"/>
+          <p:cNvPr id="387" name="Google Shape;387;p47"/>
           <p:cNvSpPr txBox="1"/>
           <p:nvPr>
             <p:ph type="title"/>
@@ -26704,7 +26778,7 @@
       </p:sp>
       <p:pic>
         <p:nvPicPr>
-          <p:cNvPr id="387" name="Google Shape;387;p47" title="WhatsApp Image 2026-10-24 at 20.25.18.jpeg"/>
+          <p:cNvPr id="388" name="Google Shape;388;p47" title="WhatsApp Image 2026-10-24 at 20.25.18.jpeg"/>
           <p:cNvPicPr preferRelativeResize="0"/>
           <p:nvPr/>
         </p:nvPicPr>
@@ -26732,7 +26806,7 @@
       </p:pic>
       <p:sp>
         <p:nvSpPr>
-          <p:cNvPr id="388" name="Google Shape;388;p47"/>
+          <p:cNvPr id="389" name="Google Shape;389;p47"/>
           <p:cNvSpPr txBox="1"/>
           <p:nvPr/>
         </p:nvSpPr>
@@ -26964,7 +27038,7 @@
             <a:tbl>
               <a:tblPr>
                 <a:noFill/>
-                <a:tableStyleId>{FA9B127D-79E6-40F0-A62D-5778406C1AF8}</a:tableStyleId>
+                <a:tableStyleId>{70CC8A99-5F05-45A2-BA69-08FDE87F0AAC}</a:tableStyleId>
               </a:tblPr>
               <a:tblGrid>
                 <a:gridCol w="1964700"/>
@@ -28080,7 +28154,7 @@
   <p:cSld>
     <p:spTree>
       <p:nvGrpSpPr>
-        <p:cNvPr id="392" name="Shape 392"/>
+        <p:cNvPr id="393" name="Shape 393"/>
         <p:cNvGrpSpPr/>
         <p:nvPr/>
       </p:nvGrpSpPr>
@@ -28094,7 +28168,7 @@
       </p:grpSpPr>
       <p:sp>
         <p:nvSpPr>
-          <p:cNvPr id="393" name="Google Shape;393;p48"/>
+          <p:cNvPr id="394" name="Google Shape;394;p48"/>
           <p:cNvSpPr txBox="1"/>
           <p:nvPr>
             <p:ph type="title"/>
@@ -28238,7 +28312,7 @@
       </p:sp>
       <p:pic>
         <p:nvPicPr>
-          <p:cNvPr id="394" name="Google Shape;394;p48" title="WhatsApp Image 2026-10-24 at 20.25.18 (1).jpeg"/>
+          <p:cNvPr id="395" name="Google Shape;395;p48" title="WhatsApp Image 2026-10-24 at 20.25.18 (1).jpeg"/>
           <p:cNvPicPr preferRelativeResize="0"/>
           <p:nvPr/>
         </p:nvPicPr>
@@ -28266,7 +28340,7 @@
       </p:pic>
       <p:sp>
         <p:nvSpPr>
-          <p:cNvPr id="395" name="Google Shape;395;p48"/>
+          <p:cNvPr id="396" name="Google Shape;396;p48"/>
           <p:cNvSpPr txBox="1"/>
           <p:nvPr/>
         </p:nvSpPr>
@@ -28394,7 +28468,7 @@
   <p:cSld>
     <p:spTree>
       <p:nvGrpSpPr>
-        <p:cNvPr id="399" name="Shape 399"/>
+        <p:cNvPr id="400" name="Shape 400"/>
         <p:cNvGrpSpPr/>
         <p:nvPr/>
       </p:nvGrpSpPr>
@@ -28408,7 +28482,7 @@
       </p:grpSpPr>
       <p:sp>
         <p:nvSpPr>
-          <p:cNvPr id="400" name="Google Shape;400;p49"/>
+          <p:cNvPr id="401" name="Google Shape;401;p49"/>
           <p:cNvSpPr txBox="1"/>
           <p:nvPr>
             <p:ph type="title"/>
@@ -28568,7 +28642,7 @@
       </p:sp>
       <p:sp>
         <p:nvSpPr>
-          <p:cNvPr id="401" name="Google Shape;401;p49"/>
+          <p:cNvPr id="402" name="Google Shape;402;p49"/>
           <p:cNvSpPr txBox="1"/>
           <p:nvPr/>
         </p:nvSpPr>
@@ -28658,7 +28732,7 @@
       </p:sp>
       <p:pic>
         <p:nvPicPr>
-          <p:cNvPr id="402" name="Google Shape;402;p49" title="R2_Score.jpeg"/>
+          <p:cNvPr id="403" name="Google Shape;403;p49" title="R2_Score.jpeg"/>
           <p:cNvPicPr preferRelativeResize="0"/>
           <p:nvPr/>
         </p:nvPicPr>
@@ -28697,7 +28771,7 @@
   <p:cSld>
     <p:spTree>
       <p:nvGrpSpPr>
-        <p:cNvPr id="407" name="Shape 407"/>
+        <p:cNvPr id="408" name="Shape 408"/>
         <p:cNvGrpSpPr/>
         <p:nvPr/>
       </p:nvGrpSpPr>
@@ -28711,7 +28785,7 @@
       </p:grpSpPr>
       <p:sp>
         <p:nvSpPr>
-          <p:cNvPr id="408" name="Google Shape;408;p50"/>
+          <p:cNvPr id="409" name="Google Shape;409;p50"/>
           <p:cNvSpPr/>
           <p:nvPr/>
         </p:nvSpPr>
@@ -28761,7 +28835,7 @@
       </p:sp>
       <p:cxnSp>
         <p:nvCxnSpPr>
-          <p:cNvPr id="409" name="Google Shape;409;p50"/>
+          <p:cNvPr id="410" name="Google Shape;410;p50"/>
           <p:cNvCxnSpPr/>
           <p:nvPr/>
         </p:nvCxnSpPr>
@@ -28787,7 +28861,7 @@
       </p:cxnSp>
       <p:sp>
         <p:nvSpPr>
-          <p:cNvPr id="410" name="Google Shape;410;p50"/>
+          <p:cNvPr id="411" name="Google Shape;411;p50"/>
           <p:cNvSpPr/>
           <p:nvPr/>
         </p:nvSpPr>
@@ -28844,7 +28918,7 @@
       </p:sp>
       <p:sp>
         <p:nvSpPr>
-          <p:cNvPr id="411" name="Google Shape;411;p50"/>
+          <p:cNvPr id="412" name="Google Shape;412;p50"/>
           <p:cNvSpPr txBox="1"/>
           <p:nvPr/>
         </p:nvSpPr>
@@ -28894,7 +28968,7 @@
       </p:sp>
       <p:cxnSp>
         <p:nvCxnSpPr>
-          <p:cNvPr id="412" name="Google Shape;412;p50"/>
+          <p:cNvPr id="413" name="Google Shape;413;p50"/>
           <p:cNvCxnSpPr/>
           <p:nvPr/>
         </p:nvCxnSpPr>
@@ -28920,7 +28994,7 @@
       </p:cxnSp>
       <p:sp>
         <p:nvSpPr>
-          <p:cNvPr id="413" name="Google Shape;413;p50"/>
+          <p:cNvPr id="414" name="Google Shape;414;p50"/>
           <p:cNvSpPr txBox="1"/>
           <p:nvPr/>
         </p:nvSpPr>
@@ -29116,7 +29190,7 @@
       </p:sp>
       <p:sp>
         <p:nvSpPr>
-          <p:cNvPr id="414" name="Google Shape;414;p50"/>
+          <p:cNvPr id="415" name="Google Shape;415;p50"/>
           <p:cNvSpPr txBox="1"/>
           <p:nvPr/>
         </p:nvSpPr>
@@ -29204,7 +29278,7 @@
       </p:sp>
       <p:sp>
         <p:nvSpPr>
-          <p:cNvPr id="415" name="Google Shape;415;p50"/>
+          <p:cNvPr id="416" name="Google Shape;416;p50"/>
           <p:cNvSpPr/>
           <p:nvPr/>
         </p:nvSpPr>
@@ -29254,7 +29328,7 @@
       </p:sp>
       <p:cxnSp>
         <p:nvCxnSpPr>
-          <p:cNvPr id="416" name="Google Shape;416;p50"/>
+          <p:cNvPr id="417" name="Google Shape;417;p50"/>
           <p:cNvCxnSpPr/>
           <p:nvPr/>
         </p:nvCxnSpPr>
@@ -29280,7 +29354,7 @@
       </p:cxnSp>
       <p:sp>
         <p:nvSpPr>
-          <p:cNvPr id="417" name="Google Shape;417;p50"/>
+          <p:cNvPr id="418" name="Google Shape;418;p50"/>
           <p:cNvSpPr txBox="1"/>
           <p:nvPr/>
         </p:nvSpPr>
@@ -29368,7 +29442,7 @@
       </p:sp>
       <p:pic>
         <p:nvPicPr>
-          <p:cNvPr id="418" name="Google Shape;418;p50"/>
+          <p:cNvPr id="419" name="Google Shape;419;p50"/>
           <p:cNvPicPr preferRelativeResize="0"/>
           <p:nvPr/>
         </p:nvPicPr>
@@ -33403,7 +33477,7 @@
                 <a:cs typeface="Arial"/>
                 <a:sym typeface="Arial"/>
               </a:rPr>
-              <a:t>Linear Model: Implementation</a:t>
+              <a:t>Linear Regression: Implementation</a:t>
             </a:r>
             <a:br>
               <a:rPr lang="en" sz="2100"/>
@@ -34766,7 +34840,7 @@
                 <a:cs typeface="Arial"/>
                 <a:sym typeface="Arial"/>
               </a:rPr>
-              <a:t>Linear Model: Implementation</a:t>
+              <a:t>Linear Regression: Implementation</a:t>
             </a:r>
             <a:br>
               <a:rPr lang="en" sz="2100"/>
@@ -36184,44 +36258,44 @@
 </file>
 
 <file path=ppt/theme/theme1.xml><?xml version="1.0" encoding="utf-8"?>
-<a:theme xmlns:a="http://schemas.openxmlformats.org/drawingml/2006/main" xmlns:r="http://schemas.openxmlformats.org/officeDocument/2006/relationships" name="Decision Tree Model: Implementation &amp; Evaluation">
+<a:theme xmlns:a="http://schemas.openxmlformats.org/drawingml/2006/main" xmlns:r="http://schemas.openxmlformats.org/officeDocument/2006/relationships">
   <a:themeElements>
-    <a:clrScheme name="Decision Tree Model: Implementation &amp; Evaluation">
+    <a:clrScheme name="Default">
       <a:dk1>
-        <a:srgbClr val="1B2A3A"/>
+        <a:srgbClr val="000000"/>
       </a:dk1>
       <a:lt1>
         <a:srgbClr val="FFFFFF"/>
       </a:lt1>
       <a:dk2>
-        <a:srgbClr val="545F6B"/>
+        <a:srgbClr val="158158"/>
       </a:dk2>
       <a:lt2>
-        <a:srgbClr val="E8EAEB"/>
+        <a:srgbClr val="F3F3F3"/>
       </a:lt2>
       <a:accent1>
-        <a:srgbClr val="B85A14"/>
+        <a:srgbClr val="058DC7"/>
       </a:accent1>
       <a:accent2>
-        <a:srgbClr val="5B6672"/>
+        <a:srgbClr val="50B432"/>
       </a:accent2>
       <a:accent3>
-        <a:srgbClr val="9AA0A6"/>
+        <a:srgbClr val="ED561B"/>
       </a:accent3>
       <a:accent4>
-        <a:srgbClr val="767F89"/>
+        <a:srgbClr val="EDEF00"/>
       </a:accent4>
       <a:accent5>
-        <a:srgbClr val="989FA6"/>
+        <a:srgbClr val="24CBE5"/>
       </a:accent5>
       <a:accent6>
-        <a:srgbClr val="BBBFC4"/>
+        <a:srgbClr val="64E572"/>
       </a:accent6>
       <a:hlink>
-        <a:srgbClr val="0563C1"/>
+        <a:srgbClr val="2200CC"/>
       </a:hlink>
       <a:folHlink>
-        <a:srgbClr val="954F72"/>
+        <a:srgbClr val="551A8B"/>
       </a:folHlink>
     </a:clrScheme>
     <a:fontScheme name="Office">
@@ -36463,44 +36537,44 @@
 </file>
 
 <file path=ppt/theme/theme2.xml><?xml version="1.0" encoding="utf-8"?>
-<a:theme xmlns:a="http://schemas.openxmlformats.org/drawingml/2006/main" xmlns:r="http://schemas.openxmlformats.org/officeDocument/2006/relationships" name="Office Theme">
+<a:theme xmlns:a="http://schemas.openxmlformats.org/drawingml/2006/main" xmlns:r="http://schemas.openxmlformats.org/officeDocument/2006/relationships" name="Decision Tree Model: Implementation &amp; Evaluation">
   <a:themeElements>
-    <a:clrScheme name="Office">
+    <a:clrScheme name="Decision Tree Model: Implementation &amp; Evaluation">
       <a:dk1>
-        <a:srgbClr val="000000"/>
+        <a:srgbClr val="1B2A3A"/>
       </a:dk1>
       <a:lt1>
         <a:srgbClr val="FFFFFF"/>
       </a:lt1>
       <a:dk2>
-        <a:srgbClr val="0E2841"/>
+        <a:srgbClr val="545F6B"/>
       </a:dk2>
       <a:lt2>
-        <a:srgbClr val="E8E8E8"/>
+        <a:srgbClr val="E8EAEB"/>
       </a:lt2>
       <a:accent1>
-        <a:srgbClr val="156082"/>
+        <a:srgbClr val="B85A14"/>
       </a:accent1>
       <a:accent2>
-        <a:srgbClr val="E97132"/>
+        <a:srgbClr val="5B6672"/>
       </a:accent2>
       <a:accent3>
-        <a:srgbClr val="196B24"/>
+        <a:srgbClr val="9AA0A6"/>
       </a:accent3>
       <a:accent4>
-        <a:srgbClr val="0F9ED5"/>
+        <a:srgbClr val="767F89"/>
       </a:accent4>
       <a:accent5>
-        <a:srgbClr val="A02B93"/>
+        <a:srgbClr val="989FA6"/>
       </a:accent5>
       <a:accent6>
-        <a:srgbClr val="4EA72E"/>
+        <a:srgbClr val="BBBFC4"/>
       </a:accent6>
       <a:hlink>
-        <a:srgbClr val="467886"/>
+        <a:srgbClr val="0563C1"/>
       </a:hlink>
       <a:folHlink>
-        <a:srgbClr val="96607D"/>
+        <a:srgbClr val="954F72"/>
       </a:folHlink>
     </a:clrScheme>
     <a:fontScheme name="Office">
@@ -37021,9 +37095,9 @@
 </file>
 
 <file path=ppt/theme/theme4.xml><?xml version="1.0" encoding="utf-8"?>
-<a:theme xmlns:a="http://schemas.openxmlformats.org/drawingml/2006/main" xmlns:r="http://schemas.openxmlformats.org/officeDocument/2006/relationships">
+<a:theme xmlns:a="http://schemas.openxmlformats.org/drawingml/2006/main" xmlns:r="http://schemas.openxmlformats.org/officeDocument/2006/relationships" name="Office Theme">
   <a:themeElements>
-    <a:clrScheme name="Default">
+    <a:clrScheme name="Office">
       <a:dk1>
         <a:srgbClr val="000000"/>
       </a:dk1>
@@ -37031,34 +37105,34 @@
         <a:srgbClr val="FFFFFF"/>
       </a:lt1>
       <a:dk2>
-        <a:srgbClr val="158158"/>
+        <a:srgbClr val="0E2841"/>
       </a:dk2>
       <a:lt2>
-        <a:srgbClr val="F3F3F3"/>
+        <a:srgbClr val="E8E8E8"/>
       </a:lt2>
       <a:accent1>
-        <a:srgbClr val="058DC7"/>
+        <a:srgbClr val="156082"/>
       </a:accent1>
       <a:accent2>
-        <a:srgbClr val="50B432"/>
+        <a:srgbClr val="E97132"/>
       </a:accent2>
       <a:accent3>
-        <a:srgbClr val="ED561B"/>
+        <a:srgbClr val="196B24"/>
       </a:accent3>
       <a:accent4>
-        <a:srgbClr val="EDEF00"/>
+        <a:srgbClr val="0F9ED5"/>
       </a:accent4>
       <a:accent5>
-        <a:srgbClr val="24CBE5"/>
+        <a:srgbClr val="A02B93"/>
       </a:accent5>
       <a:accent6>
-        <a:srgbClr val="64E572"/>
+        <a:srgbClr val="4EA72E"/>
       </a:accent6>
       <a:hlink>
-        <a:srgbClr val="2200CC"/>
+        <a:srgbClr val="467886"/>
       </a:hlink>
       <a:folHlink>
-        <a:srgbClr val="551A8B"/>
+        <a:srgbClr val="96607D"/>
       </a:folHlink>
     </a:clrScheme>
     <a:fontScheme name="Office">

</xml_diff>